<commit_message>
CI Report: Mesh Bioplastics
</commit_message>
<xml_diff>
--- a/mesh_bioplastics_CI_Report.pptx
+++ b/mesh_bioplastics_CI_Report.pptx
@@ -4909,7 +4909,7 @@
                 <a:ea typeface="Arial" pitchFamily="34" charset="-122"/>
                 <a:cs typeface="Arial" pitchFamily="34" charset="-120"/>
               </a:rPr>
-              <a:t>Material Innovation vs. Process Equipment</a:t>
+              <a:t>Material Sustainability Integration</a:t>
             </a:r>
             <a:endParaRPr lang="en-US" sz="900" dirty="0"/>
           </a:p>
@@ -4987,7 +4987,7 @@
                 <a:ea typeface="Arial" pitchFamily="34" charset="-122"/>
                 <a:cs typeface="Arial" pitchFamily="34" charset="-120"/>
               </a:rPr>
-              <a:t>Integrated Intelligence vs. Standalone Tooling</a:t>
+              <a:t>Process Intelligence Automation</a:t>
             </a:r>
             <a:endParaRPr lang="en-US" sz="900" dirty="0"/>
           </a:p>
@@ -8270,7 +8270,7 @@
                 <a:ea typeface="Arial" pitchFamily="34" charset="-122"/>
                 <a:cs typeface="Arial" pitchFamily="34" charset="-120"/>
               </a:rPr>
-              <a:t>Emeryville, United States | https://www.rjg.com</a:t>
+              <a:t>Emeryville, California, United States | https://www.rjg.com</a:t>
             </a:r>
             <a:endParaRPr lang="en-US" sz="900" dirty="0"/>
           </a:p>
@@ -8888,7 +8888,7 @@
                 <a:ea typeface="Arial" pitchFamily="34" charset="-122"/>
                 <a:cs typeface="Arial" pitchFamily="34" charset="-120"/>
               </a:rPr>
-              <a:t>Direct contact, reputation-based (Avvo, Martindale-Hubbell ratings)</a:t>
+              <a:t>Direct contact, referrals from other attorneys</a:t>
             </a:r>
             <a:endParaRPr lang="en-US" sz="900" dirty="0"/>
           </a:p>
@@ -8991,7 +8991,7 @@
                 <a:ea typeface="Arial" pitchFamily="34" charset="-122"/>
                 <a:cs typeface="Arial" pitchFamily="34" charset="-120"/>
               </a:rPr>
-              <a:t>Trademark applications, copyright, entertainment law expertise</a:t>
+              <a:t>Trademark, copyright, entertainment law with 500+ applications handled</a:t>
             </a:r>
             <a:endParaRPr lang="en-US" sz="900" dirty="0"/>
           </a:p>
@@ -9094,7 +9094,7 @@
                 <a:ea typeface="Arial" pitchFamily="34" charset="-122"/>
                 <a:cs typeface="Arial" pitchFamily="34" charset="-120"/>
               </a:rPr>
-              <a:t>500+ trademark applications and registrations to credit</a:t>
+              <a:t>Unknown</a:t>
             </a:r>
             <a:endParaRPr lang="en-US" sz="900" dirty="0"/>
           </a:p>
@@ -9403,7 +9403,7 @@
                 <a:ea typeface="Arial" pitchFamily="34" charset="-122"/>
                 <a:cs typeface="Arial" pitchFamily="34" charset="-120"/>
               </a:rPr>
-              <a:t>Entertainment industry producers, directors, actors, musicians</a:t>
+              <a:t>Entertainment producers, directors, musicians, authors, trademark applicants</a:t>
             </a:r>
             <a:endParaRPr lang="en-US" sz="900" dirty="0"/>
           </a:p>
@@ -9506,7 +9506,7 @@
                 <a:ea typeface="Arial" pitchFamily="34" charset="-122"/>
                 <a:cs typeface="Arial" pitchFamily="34" charset="-120"/>
               </a:rPr>
-              <a:t>Intellectual property and entertainment law counsel services</a:t>
+              <a:t>Intellectual property and entertainment law services expertise</a:t>
             </a:r>
             <a:endParaRPr lang="en-US" sz="900" dirty="0"/>
           </a:p>
@@ -9847,7 +9847,7 @@
                 <a:ea typeface="Arial" pitchFamily="34" charset="-122"/>
                 <a:cs typeface="Arial" pitchFamily="34" charset="-120"/>
               </a:rPr>
-              <a:t>Unknown | https://www.kistler.com</a:t>
+              <a:t>Sindelfingen, Germany | https://www.kistler.com</a:t>
             </a:r>
             <a:endParaRPr lang="en-US" sz="900" dirty="0"/>
           </a:p>
@@ -10465,7 +10465,7 @@
                 <a:ea typeface="Arial" pitchFamily="34" charset="-122"/>
                 <a:cs typeface="Arial" pitchFamily="34" charset="-120"/>
               </a:rPr>
-              <a:t>Product finder, online catalog, direct website</a:t>
+              <a:t>Website product finders, industry verticals</a:t>
             </a:r>
             <a:endParaRPr lang="en-US" sz="900" dirty="0"/>
           </a:p>
@@ -10568,7 +10568,7 @@
                 <a:ea typeface="Arial" pitchFamily="34" charset="-122"/>
                 <a:cs typeface="Arial" pitchFamily="34" charset="-120"/>
               </a:rPr>
-              <a:t>IEPE piezoelectric sensors, force sensors, accelerometers</a:t>
+              <a:t>IEPE piezoelectric sensors, force sensors, accelerometers for measurement</a:t>
             </a:r>
             <a:endParaRPr lang="en-US" sz="900" dirty="0"/>
           </a:p>
@@ -10980,7 +10980,7 @@
                 <a:ea typeface="Arial" pitchFamily="34" charset="-122"/>
                 <a:cs typeface="Arial" pitchFamily="34" charset="-120"/>
               </a:rPr>
-              <a:t>Industrial measurement and vibration monitoring applications</a:t>
+              <a:t>Industrial measurement, automotive, vibration monitoring applications</a:t>
             </a:r>
             <a:endParaRPr lang="en-US" sz="900" dirty="0"/>
           </a:p>
@@ -11083,7 +11083,7 @@
                 <a:ea typeface="Arial" pitchFamily="34" charset="-122"/>
                 <a:cs typeface="Arial" pitchFamily="34" charset="-120"/>
               </a:rPr>
-              <a:t>Precision measurement sensors for industrial applications</a:t>
+              <a:t>Advanced sensor measurement technology for industrial applications</a:t>
             </a:r>
             <a:endParaRPr lang="en-US" sz="900" dirty="0"/>
           </a:p>
@@ -12042,7 +12042,7 @@
                 <a:ea typeface="Arial" pitchFamily="34" charset="-122"/>
                 <a:cs typeface="Arial" pitchFamily="34" charset="-120"/>
               </a:rPr>
-              <a:t>Content marketing, product pages, consultative approach</a:t>
+              <a:t>Website content marketing, product demonstrations, consultative sales</a:t>
             </a:r>
             <a:endParaRPr lang="en-US" sz="900" dirty="0"/>
           </a:p>
@@ -12145,7 +12145,7 @@
                 <a:ea typeface="Arial" pitchFamily="34" charset="-122"/>
                 <a:cs typeface="Arial" pitchFamily="34" charset="-120"/>
               </a:rPr>
-              <a:t>Hot runner systems, flow control, IntelliGate digital sensors</a:t>
+              <a:t>Hot runner systems, IntelliGate digital sensor technology, flow control</a:t>
             </a:r>
             <a:endParaRPr lang="en-US" sz="900" dirty="0"/>
           </a:p>
@@ -12248,7 +12248,7 @@
                 <a:ea typeface="Arial" pitchFamily="34" charset="-122"/>
                 <a:cs typeface="Arial" pitchFamily="34" charset="-120"/>
               </a:rPr>
-              <a:t>50+ years experience, long-standing customer relationships</a:t>
+              <a:t>Unknown</a:t>
             </a:r>
             <a:endParaRPr lang="en-US" sz="900" dirty="0"/>
           </a:p>
@@ -12557,7 +12557,7 @@
                 <a:ea typeface="Arial" pitchFamily="34" charset="-122"/>
                 <a:cs typeface="Arial" pitchFamily="34" charset="-120"/>
               </a:rPr>
-              <a:t>Plastics injection molding manufacturers worldwide</a:t>
+              <a:t>Injection molding manufacturers, plastics processors</a:t>
             </a:r>
             <a:endParaRPr lang="en-US" sz="900" dirty="0"/>
           </a:p>
@@ -12660,7 +12660,7 @@
                 <a:ea typeface="Arial" pitchFamily="34" charset="-122"/>
                 <a:cs typeface="Arial" pitchFamily="34" charset="-120"/>
               </a:rPr>
-              <a:t>Hot runner solutions to improve injection molding efficiency</a:t>
+              <a:t>Sophisticated hot runner solutions for injection molding innovation</a:t>
             </a:r>
             <a:endParaRPr lang="en-US" sz="900" dirty="0"/>
           </a:p>
@@ -12763,7 +12763,7 @@
                 <a:ea typeface="Arial" pitchFamily="34" charset="-122"/>
                 <a:cs typeface="Arial" pitchFamily="34" charset="-120"/>
               </a:rPr>
-              <a:t>New IntelliGate Hot Runner with digital sensor technology launched</a:t>
+              <a:t>IntelliGate Hot Runner product launch with digital sensor technology</a:t>
             </a:r>
             <a:endParaRPr lang="en-US" sz="900" dirty="0"/>
           </a:p>
@@ -14548,7 +14548,7 @@
                           <a:ea typeface="Arial" pitchFamily="34" charset="-122"/>
                           <a:cs typeface="Arial" pitchFamily="34" charset="-120"/>
                         </a:rPr>
-                        <a:t>Product finder</a:t>
+                        <a:t>Website product finders</a:t>
                       </a:r>
                       <a:endParaRPr lang="en-US" sz="800" dirty="0">
                         <a:latin typeface="Arial" charset="0"/>
@@ -14616,7 +14616,7 @@
                           <a:ea typeface="Arial" pitchFamily="34" charset="-122"/>
                           <a:cs typeface="Arial" pitchFamily="34" charset="-120"/>
                         </a:rPr>
-                        <a:t>Content marketing</a:t>
+                        <a:t>Website content marketing</a:t>
                       </a:r>
                       <a:endParaRPr lang="en-US" sz="800" dirty="0">
                         <a:latin typeface="Arial" charset="0"/>
@@ -14822,7 +14822,7 @@
                           <a:ea typeface="Arial" pitchFamily="34" charset="-122"/>
                           <a:cs typeface="Arial" pitchFamily="34" charset="-120"/>
                         </a:rPr>
-                        <a:t>Trademark applications</a:t>
+                        <a:t>Trademark</a:t>
                       </a:r>
                       <a:endParaRPr lang="en-US" sz="800" dirty="0">
                         <a:latin typeface="Arial" charset="0"/>
@@ -15164,7 +15164,7 @@
                           <a:ea typeface="Arial" pitchFamily="34" charset="-122"/>
                           <a:cs typeface="Arial" pitchFamily="34" charset="-120"/>
                         </a:rPr>
-                        <a:t>500+ trademark applications and registrations to credit</a:t>
+                        <a:t>Unknown</a:t>
                       </a:r>
                       <a:endParaRPr lang="en-US" sz="800" dirty="0">
                         <a:latin typeface="Arial" charset="0"/>
@@ -15300,7 +15300,7 @@
                           <a:ea typeface="Arial" pitchFamily="34" charset="-122"/>
                           <a:cs typeface="Arial" pitchFamily="34" charset="-120"/>
                         </a:rPr>
-                        <a:t>50+ years experience</a:t>
+                        <a:t>Unknown</a:t>
                       </a:r>
                       <a:endParaRPr lang="en-US" sz="800" dirty="0">
                         <a:latin typeface="Arial" charset="0"/>
@@ -16190,7 +16190,7 @@
                           <a:ea typeface="Arial" pitchFamily="34" charset="-122"/>
                           <a:cs typeface="Arial" pitchFamily="34" charset="-120"/>
                         </a:rPr>
-                        <a:t>Entertainment industry producers</a:t>
+                        <a:t>Entertainment producers</a:t>
                       </a:r>
                       <a:endParaRPr lang="en-US" sz="800" dirty="0">
                         <a:latin typeface="Arial" charset="0"/>
@@ -16258,7 +16258,7 @@
                           <a:ea typeface="Arial" pitchFamily="34" charset="-122"/>
                           <a:cs typeface="Arial" pitchFamily="34" charset="-120"/>
                         </a:rPr>
-                        <a:t>Industrial measurement and vibration monitoring applications</a:t>
+                        <a:t>Industrial measurement</a:t>
                       </a:r>
                       <a:endParaRPr lang="en-US" sz="800" dirty="0">
                         <a:latin typeface="Arial" charset="0"/>
@@ -16326,7 +16326,7 @@
                           <a:ea typeface="Arial" pitchFamily="34" charset="-122"/>
                           <a:cs typeface="Arial" pitchFamily="34" charset="-120"/>
                         </a:rPr>
-                        <a:t>Plastics injection molding manufacturers worldwide</a:t>
+                        <a:t>Injection molding manufacturers</a:t>
                       </a:r>
                       <a:endParaRPr lang="en-US" sz="800" dirty="0">
                         <a:latin typeface="Arial" charset="0"/>
@@ -16532,7 +16532,7 @@
                           <a:ea typeface="Arial" pitchFamily="34" charset="-122"/>
                           <a:cs typeface="Arial" pitchFamily="34" charset="-120"/>
                         </a:rPr>
-                        <a:t>Intellectual property and entertainment law counsel services</a:t>
+                        <a:t>Intellectual property and entertainment law services expertise</a:t>
                       </a:r>
                       <a:endParaRPr lang="en-US" sz="800" dirty="0">
                         <a:latin typeface="Arial" charset="0"/>
@@ -16600,7 +16600,7 @@
                           <a:ea typeface="Arial" pitchFamily="34" charset="-122"/>
                           <a:cs typeface="Arial" pitchFamily="34" charset="-120"/>
                         </a:rPr>
-                        <a:t>Precision measurement sensors for industrial applications</a:t>
+                        <a:t>Advanced sensor measurement technology for industrial applications</a:t>
                       </a:r>
                       <a:endParaRPr lang="en-US" sz="800" dirty="0">
                         <a:latin typeface="Arial" charset="0"/>
@@ -16668,7 +16668,7 @@
                           <a:ea typeface="Arial" pitchFamily="34" charset="-122"/>
                           <a:cs typeface="Arial" pitchFamily="34" charset="-120"/>
                         </a:rPr>
-                        <a:t>Hot runner solutions to improve injection molding efficiency</a:t>
+                        <a:t>Sophisticated hot runner solutions for injection molding innovation</a:t>
                       </a:r>
                       <a:endParaRPr lang="en-US" sz="800" dirty="0">
                         <a:latin typeface="Arial" charset="0"/>
@@ -17010,7 +17010,7 @@
                           <a:ea typeface="Arial" pitchFamily="34" charset="-122"/>
                           <a:cs typeface="Arial" pitchFamily="34" charset="-120"/>
                         </a:rPr>
-                        <a:t>New IntelliGate Hot Runner with digital sensor technology launched</a:t>
+                        <a:t>IntelliGate Hot Runner product launch with digital sensor technology</a:t>
                       </a:r>
                       <a:endParaRPr lang="en-US" sz="800" dirty="0">
                         <a:latin typeface="Arial" charset="0"/>

</xml_diff>